<commit_message>
Rewrite speaker notes as first-person scripts the presenter actually says
The previous notes were stage directions ('Open by introducing yourself...').
The new notes are the actual words Cagri will say to the room: first person,
conversational, with rhetorical questions where appropriate.

scripts/patch_notes.py opens the existing pptx, replaces the notes on every
slide in order, and writes the file back. Re-run after any future structural
edits if the notes drift out of sync.
</commit_message>
<xml_diff>
--- a/WSU-Workshop-May15.pptx
+++ b/WSU-Workshop-May15.pptx
@@ -557,7 +557,7 @@
           <a:lstStyle/>
           <a:p>
             <a:r>
-              <a:t>Open by introducing yourself in one sentence. Cagri Temel, CTO of Hezarfen LLC, IEEE Senior Member. Tell them what they will get in the next 165 minutes: they will build, break, and explain a real machine learning model trained on NASA turbofan data. Set the tone now: this is hands-on, not a passive lecture. Pause for two seconds after the title slide before advancing.</a:t>
+              <a:t>Good morning everyone. I'm Cagri Temel, CTO at Hezarfen LLC. For the next two hours and forty-five minutes you're going to do something most people don't get to do until they're in industry: you're going to train a real machine learning model on real NASA data, you're going to break it on purpose, and then you're going to explain exactly how it makes its decisions. By the end of the session you'll have a working model on your laptop, you'll know which sensor failed on an aircraft engine, and many of you will have your first open-source contribution on GitHub. Let's get started.</a:t>
             </a:r>
           </a:p>
         </p:txBody>
@@ -627,7 +627,7 @@
           <a:lstStyle/>
           <a:p>
             <a:r>
-              <a:t>Dramatic pause. Just say 'No.' Then count to two in your head before continuing. 'Regulators don't ask how accurate your model is. They ask why your model said that.' Then list the regulators: FAA for aviation, FDA for medical devices, OCC for banking, EU AI Act for everything in Europe. Tell them this is not theory. This is what blocks AI systems from shipping in regulated industries.</a:t>
+              <a:t>No. Regulators don't ask, how accurate is your model. They ask, why did your model say that? And if you can't answer that question in a way a non-engineer can follow, your model doesn't ship. FAA for aviation. FDA for medical devices. OCC for banking. EU AI Act for anything that touches a European customer. This isn't theory. This is what actually blocks AI systems from being deployed in regulated industries.</a:t>
             </a:r>
           </a:p>
         </p:txBody>
@@ -697,7 +697,7 @@
           <a:lstStyle/>
           <a:p>
             <a:r>
-              <a:t>Frame the binary that students believe in: high accuracy means black box, interpretability means low accuracy. Walk through the two cards. End with the question that the next 90 minutes will answer: 'Can we have both?' Pause briefly. Yes, we can. That's where soft decision trees come in.</a:t>
+              <a:t>So you're stuck between two worlds. On one side, black-box models like LSTMs and transformers. High accuracy, but you can't explain why. On the other side, glass-box models like classic decision trees or linear regression. Fully explainable, but lower accuracy. Regulators love glass boxes. Engineers prefer black boxes. So the question today is: can we have both?</a:t>
             </a:r>
           </a:p>
         </p:txBody>
@@ -767,7 +767,7 @@
           <a:lstStyle/>
           <a:p>
             <a:r>
-              <a:t>Classic decision tree, the kind you would draw on a whiteboard. Show the structure. Say it loud: 'beautifully explainable.' Then the catch: 'often poor accuracy, because hard splits are brittle.' Set up the next two slides: hard split versus soft split.</a:t>
+              <a:t>You've all seen a decision tree before. Beautiful structure. Sensor 11 is above the threshold, go left; below, go right. It's the most explainable model that exists. But classic decision trees often have worse accuracy than neural networks. Why? Because the splits are hard. A 0.01 difference in a sensor value flips the entire path. That brittleness is what limits accuracy.</a:t>
             </a:r>
           </a:p>
         </p:txBody>
@@ -837,7 +837,7 @@
           <a:lstStyle/>
           <a:p>
             <a:r>
-              <a:t>Students will not type this code. It is here for illustration. Walk through it: 'if x is bigger than threshold, go right. Otherwise, go left.' Output is a string. Discrete. No gradient. Tell them why this matters: 'No gradient means no backpropagation. You build the tree node by node, greedily, and you cannot train it end to end.'</a:t>
+              <a:t>This is the code for a hard split. You are NOT typing this. It's here for illustration. If x is bigger than the threshold, return right. Otherwise, return left. The output is a string. Discrete. No gradient. And no gradient means no backpropagation. You build the tree node by node, greedily. You cannot train it end to end like a neural network.</a:t>
             </a:r>
           </a:p>
         </p:txBody>
@@ -907,7 +907,7 @@
           <a:lstStyle/>
           <a:p>
             <a:r>
-              <a:t>Same code, one substitution. The if-else becomes a sigmoid. Output is now a probability between 0 and 1. Tell them: 'this is the only change. One line. But because the output is continuous, gradient flows. You can train the whole tree end-to-end with backpropagation.' That single change is what makes the rest of the workshop possible.</a:t>
+              <a:t>Now look at this. Same function. One substitution. The if-else becomes a sigmoid. Now the output is a probability, somewhere between zero and one. Continuous. And because it's continuous, gradient flows through it. That single change is what makes everything we do today possible. A tree you can train with backpropagation, just like a neural network.</a:t>
             </a:r>
           </a:p>
         </p:txBody>
@@ -977,7 +977,7 @@
           <a:lstStyle/>
           <a:p>
             <a:r>
-              <a:t>Show the structure: every internal node is a sigmoid split. Every leaf has a class distribution. The final prediction is a weighted sum of all leaves, weighted by the probability of reaching each leaf along the way. This is mathematically a smooth function from input to class probabilities, fully differentiable.</a:t>
+              <a:t>Here's what the whole tree looks like. Every internal node is a sigmoid split. Every leaf has a class distribution: Critical, Caution, Healthy probabilities. The final prediction is a weighted sum of all the leaves, weighted by the probability of reaching each leaf. Mathematically, it's smooth. Fully differentiable end to end.</a:t>
             </a:r>
           </a:p>
         </p:txBody>
@@ -1047,7 +1047,7 @@
           <a:lstStyle/>
           <a:p>
             <a:r>
-              <a:t>Summarize the key insight in one breath: 'From the tree, you get path traceability, per-feature thresholds, human-readable rules. From the network, you get end-to-end training and the accuracy that comes with it. You get both. That is why soft decision trees matter.'</a:t>
+              <a:t>And here's the win. From the tree side, you keep path traceability, per-feature thresholds, human-readable rules. From the network side, you get end-to-end training and the accuracy that comes with it. You get both. That's why soft decision trees matter for regulated industries.</a:t>
             </a:r>
           </a:p>
         </p:txBody>
@@ -1117,7 +1117,7 @@
           <a:lstStyle/>
           <a:p>
             <a:r>
-              <a:t>Three properties matter for safety-critical AI: explainability, noise robustness, and sensor-failure tolerance. Read each one. Tell the audience: 'You will see all three demonstrated in the next 90 minutes, not on a slide, on your own laptop.'</a:t>
+              <a:t>Three properties make this approach work for safety-critical AI. One, explainability. Every prediction comes with the path that produced it. Two, noise robustness. Soft splits don't break when a sensor wobbles a little. Three, sensor failure tolerance. When you train with channel-level dropout, the model learns to operate even when some sensors are missing. You'll see all three in the next ninety minutes. Not on a slide. On your own laptop.</a:t>
             </a:r>
           </a:p>
         </p:txBody>
@@ -1187,7 +1187,7 @@
           <a:lstStyle/>
           <a:p>
             <a:r>
-              <a:t>Show the numbers. Two key takeaways. First: on clean data, Temporal Neural Tree is within 0.3 RMSE of an LSTM. Effectively equal. Second: when 30 percent of sensors are missing, the LSTM degrades by 89 percent. The Temporal Neural Tree degrades by only 17 percent. Five times more robust. And it is fully explainable. This is the headline result from the paper that motivates the rest of the workshop.</a:t>
+              <a:t>These are the numbers from my paper. On clean CMAPSS data, an LSTM gets RMSE 15.49 cycles. The Temporal Neural Tree, the variant we use, gets 15.78. Essentially equal. Now look at the next column. When thirty percent of the sensors are missing — which happens in real aircraft, sensors break — the LSTM degrades by eighty-nine percent. The Temporal Neural Tree degrades by only seventeen percent. Five times more robust. And it's fully explainable. That's the headline result.</a:t>
             </a:r>
           </a:p>
         </p:txBody>
@@ -1257,7 +1257,7 @@
           <a:lstStyle/>
           <a:p>
             <a:r>
-              <a:t>Introduce the tool. 'neural-trees, on PyPI. Open source, MIT license. Scikit-learn compatible API: fit, predict, predict_proba, score. PyTorch backend. I wrote this library. Today we will all use it together.' Mention briefly that the GitHub Sprint at the end will let them contribute back.</a:t>
+              <a:t>The tool you'll use is called neural-trees. I wrote it. It's on PyPI, MIT licensed, open source. The API follows scikit-learn, so if you've used scikit-learn before you already know how to use this: fit, predict, predict_proba, score. The backend is PyTorch. You don't need a GPU; CPU is fine for everything we do today. And at the end of the workshop, you'll get a chance to contribute back to it.</a:t>
             </a:r>
           </a:p>
         </p:txBody>
@@ -1327,7 +1327,7 @@
           <a:lstStyle/>
           <a:p>
             <a:r>
-              <a:t>Spend 30 seconds here at most. Bio is on the slide, do not read it line by line. Emphasize the last bullet: 'In two hours and forty-five minutes, you will build, break, and explain a real model.' That sets the contract for the day. Move on as soon as you finish that line.</a:t>
+              <a:t>Quick about me. I'm CTO of a company called Hezarfen, where we build explainable AI for industries that have to answer to regulators: banks, insurers, healthcare, aviation. I'm an IEEE Senior Member. I also maintain a Python package called neural-trees, and that's what we'll use today. Don't memorize any of this. The only thing I want you to take away from this slide is the bottom line: in two hours and forty-five minutes, you build, you break, and you explain a real model.</a:t>
             </a:r>
           </a:p>
         </p:txBody>
@@ -1397,7 +1397,7 @@
           <a:lstStyle/>
           <a:p>
             <a:r>
-              <a:t>Activity 1 starts now. The tone shifts: you are no longer lecturing, you are running an activity. Tell them: 'For the next 55 minutes you do the work. I walk around. If anyone gets stuck, raise a hand and I will come.' Then point to the QR code on the next slide.</a:t>
+              <a:t>Okay. We're moving from lecture to hands-on now. The next fifty-five minutes are yours. You're going to train your own neural tree on the NASA data we just talked about. I'm going to walk around. If you get stuck, raise a hand, I'll come help. There are eleven steps. Each step is on a slide. You paste the code, run it, and check that the output matches mine. Ready? Let's go.</a:t>
             </a:r>
           </a:p>
         </p:txBody>
@@ -1467,7 +1467,7 @@
           <a:lstStyle/>
           <a:p>
             <a:r>
-              <a:t>Leave this slide up for two full minutes. Watch the room. Most students will scan with their phone and open Colab on the laptop using the link. If anyone looks confused, walk over and help them. Do not advance until at least 80 percent of the room is on the Colab notebook.</a:t>
+              <a:t>Pull out your phones and scan this QR code. It opens our workshop landing page. Tap Activity 1. That opens a Google Colab notebook on your laptop. Sign in with your Gmail, then click Copy to Drive so you have your own editable copy. Run the first cell to make sure everything works. I'll give you two minutes. Raise your hand if you get stuck.</a:t>
             </a:r>
           </a:p>
         </p:txBody>
@@ -1537,7 +1537,7 @@
           <a:lstStyle/>
           <a:p>
             <a:r>
-              <a:t>Show the agenda for the next 55 minutes. Emphasize step 5 as the heart of the workshop: they will literally read out the rule the model used. Most students will get through the first three steps quickly. The traverse-a-prediction step is where the meaning lands. Promise them that if they walk out remembering anything, it should be that step.</a:t>
+              <a:t>Quick overview of the next fifty-five minutes. Six main stages. We load CMAPSS and look at it. Bin the labels into three classes. Train the Soft Decision Tree, which takes about a minute. Evaluate it with a confusion matrix. And then — this is the step that matters most — we traverse one prediction. We literally read out the rule the model used. If you remember one thing from this entire workshop, it should be that step. Let's start.</a:t>
             </a:r>
           </a:p>
         </p:txBody>
@@ -1607,7 +1607,7 @@
           <a:lstStyle/>
           <a:p>
             <a:r>
-              <a:t>Step 1, imports. This cell installs nothing on Colab because everything is pre-installed; on local Python the conda env should already have neural-trees. Say: 'Paste this, run, expect to see All set.' Then walk around. Common failure: indentation errors from paste. Fix is Cmd+A then Shift+Tab.</a:t>
+              <a:t>First step, imports. Paste this code into a fresh cell. Hit Shift+Enter. You should see All set. If you get an IndentationError, that means one of your lines has a stray space at the beginning. Copy-paste does that sometimes. Click into the cell, hit Command-A to select everything, then Shift+Tab to clear indentation, and run again.</a:t>
             </a:r>
           </a:p>
         </p:txBody>
@@ -1677,7 +1677,7 @@
           <a:lstStyle/>
           <a:p>
             <a:r>
-              <a:t>Step 2 loads the CMAPSS FD001 file as a pandas dataframe. Tell the room: '100 engines, 21 sensors each, 20,631 total rows.' If a student gets FileNotFoundError, the previous wget cell did not run.</a:t>
+              <a:t>Now we load the data. CMAPSS comes as a plain text file with no headers, so we tell pandas what to call the columns. After this runs, you should see two things. The shape, twenty thousand six hundred and thirty-one rows by twenty-six columns. And the number of engines, one hundred. The first five rows show you engine 1 at cycle 1 through cycle 5. Those numbers — temperatures, pressures, fan speeds — those are exactly what a real flight data recorder logs.</a:t>
             </a:r>
           </a:p>
         </p:txBody>
@@ -1747,7 +1747,7 @@
           <a:lstStyle/>
           <a:p>
             <a:r>
-              <a:t>Step 3 computes the supervised label. For each row, RUL is the engine's max cycle minus current cycle. Capped at 125 because longer predictions are not useful. Healthy engines have RUL near 125, dying engines have RUL near 0.</a:t>
+              <a:t>Step 3 computes the label we're going to predict. For each row, RUL equals the engine's max cycle minus the current cycle. We cap it at 125. After this runs, you'll see five rows of engine 1. All five show RUL equal to 125, because at the start of the engine's life, the real RUL is way above 125, but we capped it. That's expected.</a:t>
             </a:r>
           </a:p>
         </p:txBody>
@@ -1817,7 +1817,7 @@
           <a:lstStyle/>
           <a:p>
             <a:r>
-              <a:t>Step 4 produces a four-panel plot. Sensor 2, 11, 14 trend up; sensor 7 trends down. This is the first aha moment for students: the data does tell the story of wear and tear. If a student's plot is missing one of the panels, they likely typed a different engine_id.</a:t>
+              <a:t>Now we visualize. We're going to plot four sensors for engine 1 across its entire one hundred and ninety-two cycle life. After this runs, you should see a two-by-two plot. Look at it closely. Sensor 2 — temperature — goes up over time. Sensor 11 — pressure — goes up. Sensor 14 — corrected core speed — goes up. But sensor 7 — pressure at the HPC outlet — goes down. That's the engine wearing out. Temperatures rising, compressor pressure dropping. The data is telling us the story of failure. Now we have to teach a model to see it.</a:t>
             </a:r>
           </a:p>
         </p:txBody>
@@ -1887,7 +1887,7 @@
           <a:lstStyle/>
           <a:p>
             <a:r>
-              <a:t>Step 5 turns RUL into a 3-class problem: Critical, Caution, Healthy. Tell the audience the class distribution is imbalanced. We will use stratify in the train/test split to preserve that ratio.</a:t>
+              <a:t>We're going to turn this into a classification problem. RUL is a number, but in real aviation operations, no one says 'this engine has forty-seven cycles left.' They say 'this engine is healthy,' or 'caution,' or 'critical.' So we bin RUL into three classes. Below 30 is Critical. Thirty to eighty is Caution. Above eighty is Healthy. When you run this, you should see roughly fourteen percent Critical, twenty-four percent Caution, sixty-one percent Healthy. The classes are imbalanced. That's reality. Most of the time the engine is fine.</a:t>
             </a:r>
           </a:p>
         </p:txBody>
@@ -1957,7 +1957,7 @@
           <a:lstStyle/>
           <a:p>
             <a:r>
-              <a:t>Step 6 drops the six constant sensors that carry no information. Then standardizes everything to zero mean and unit variance. Soft Decision Trees do not strictly require standardization, but the sigmoid splits behave better with it.</a:t>
+              <a:t>Now we drop the six sensors that are constant. They carry no information. That leaves fifteen informative sensors. Then we standardize. Every column gets zero mean and unit variance. Soft decision trees don't strictly require standardization, but the sigmoid splits behave much better when the input is on a consistent scale. After this runs, you should see X shape twenty thousand by fifteen, y shape twenty thousand.</a:t>
             </a:r>
           </a:p>
         </p:txBody>
@@ -2027,7 +2027,7 @@
           <a:lstStyle/>
           <a:p>
             <a:r>
-              <a:t>Step 7, standard train/test split. Stratify by y so the class ratio is preserved. Random state 42 so everyone gets the same numbers.</a:t>
+              <a:t>Standard train-test split. Eighty percent training, twenty percent test. Two things matter. Stratify equals y, which preserves the class ratio in both sets. And random state equals forty-two, so everyone in this room gets the exact same numbers. If yours don't match, you typed something wrong. After this you should see sixteen thousand five hundred and four rows for train, four thousand one hundred and twenty-seven for test.</a:t>
             </a:r>
           </a:p>
         </p:txBody>
@@ -2097,7 +2097,7 @@
           <a:lstStyle/>
           <a:p>
             <a:r>
-              <a:t>This is the framing slide. Say: 'We are going to look at data-driven decisions, specifically in settings where being wrong is expensive — lives, money, certifications.' Then announce the case: 'a turbofan engine that needs to predict its own failure.' Pause briefly before going to the hook slide. The hook slide is intentionally minimal.</a:t>
+              <a:t>For the next few hours we're going to look at one specific question. How do we make data-driven systems trustworthy in places where getting them wrong is expensive? Our case study today is a turbofan engine, the kind that powers passenger jets, that has to predict its own failure before it happens. By the end of the session you'll understand why this is harder than it looks, and why being accurate is not enough.</a:t>
             </a:r>
           </a:p>
         </p:txBody>
@@ -2167,7 +2167,7 @@
           <a:lstStyle/>
           <a:p>
             <a:r>
-              <a:t>Step 8 is the slow one. 30 to 60 seconds on CPU. While the model trains, use the time to tell the audience what is happening: 'PyTorch is doing backprop on 16,504 rows for 30 epochs. Once it finishes, we will have a tree that we can read.'</a:t>
+              <a:t>Okay, this is the slow one. About thirty to sixty seconds on CPU. While we wait, let me tell you what's happening. PyTorch is doing backpropagation on sixteen thousand rows for thirty epochs. Every epoch, the loss should come down a little. When it finishes, you should see test accuracy around 0.84. If yours lands anywhere between 0.82 and 0.86, that's normal — randomness in training varies a little across machines. While we wait — quick question. What do you think an LSTM would get on the same problem? Right. About the same. The point is not accuracy. The point is what we can do with the model next.</a:t>
             </a:r>
           </a:p>
         </p:txBody>
@@ -2237,7 +2237,7 @@
           <a:lstStyle/>
           <a:p>
             <a:r>
-              <a:t>Step 9, the confusion matrix. Two things to highlight on the matrix. First, the bottom-left zero: no Healthy engine was wrongly flagged as Critical. Second, only 5 of 600 Critical engines were missed and called Healthy. In aviation, you want both numbers small. Critical-recall must be high.</a:t>
+              <a:t>Now we look at where the model is right and where it's wrong. You should see a confusion matrix, three by three, color-coded. Look at the bottom-left cell. It should say zero. That means: out of every Healthy engine in the test set, the model wrongly flagged zero of them as Critical. We never raised a false alarm. Now look at the top row. Out of six hundred Critical engines, we caught about four hundred and ninety. We missed some, but only five of those misses went all the way to Healthy. In aviation language: we don't miss many dangerous engines, and we don't waste healthy ones. That's a useful model.</a:t>
             </a:r>
           </a:p>
         </p:txBody>
@@ -2307,7 +2307,7 @@
           <a:lstStyle/>
           <a:p>
             <a:r>
-              <a:t>Step 10 is the first peek inside the model. For each of the 15 internal nodes, we print the sensor with the largest absolute weight: that node's dominant feature. Three sensors will dominate the tree: s7, s14, s6. This is feature importance, but computed natively from the model itself, not post-hoc.</a:t>
+              <a:t>Now we peek inside the model. Soft decision trees have fifteen internal nodes — one root, then it branches out. For each internal node, we ask: which sensor does this node lean on the most? When you run this, you'll see fifteen nodes and their dominant sensors. Notice some sensors show up multiple times. Sensor 14 and sensor 6, in particular. Those are the pillars of the model. If those sensors go bad, the model is in trouble. Remember sensor 14. It comes back in Activity 2.</a:t>
             </a:r>
           </a:p>
         </p:txBody>
@@ -2377,7 +2377,7 @@
           <a:lstStyle/>
           <a:p>
             <a:r>
-              <a:t>Step 11 is the punchline of Activity 1. Once everyone has the output, pause and project this slide. Walk through it on stage: 'The model predicted Healthy with 85 percent confidence, only 15 percent Caution, and zero probability of Critical. It says the root node leaned on sensor 7. If a regulator asks why, we can say sensor 7 was above the model's threshold and that drove the decision. An LSTM cannot give you this answer. That is the entire point of the workshop.'</a:t>
+              <a:t>This is the step that matters most. We pick one specific test sample, sample 17, and we ask the model: what did you predict, with what confidence, and which sensor did you look at first? When you run this, you should see four lines. Read them out loud to yourself. The model predicted Healthy with eighty-five percent confidence. Zero percent Critical. The root node leaned on sensor 7, HPC outlet pressure. Now imagine you have to explain this prediction to a regulator. With this output, you can say: 'My model classified this engine as Healthy because the static pressure at the high-pressure compressor outlet was above its decision threshold.' An LSTM cannot give you this answer. That's why we did all of this.</a:t>
             </a:r>
           </a:p>
         </p:txBody>
@@ -2447,7 +2447,7 @@
           <a:lstStyle/>
           <a:p>
             <a:r>
-              <a:t>Checkpoint. Acknowledge what they have built so far. Three deliverables: a trained model, accuracy above 80 percent, a decision path printed for one engine. Announce the break and the start of Activity 2. During the break, watch for students who did not complete step 11. Help them in the break.</a:t>
+              <a:t>Okay. Take a breath. By now you should have three things on your screen: a trained Soft Decision Tree, test accuracy above eighty percent, and a printed decision path for engine 17. If you're missing one of those, find me during the break and we'll catch up. Ten minutes break. Get coffee, stretch. When you come back at ten thirty-five, we run the team competition.</a:t>
             </a:r>
           </a:p>
         </p:txBody>
@@ -2517,7 +2517,7 @@
           <a:lstStyle/>
           <a:p>
             <a:r>
-              <a:t>Activity 2 is the team competition. Tone shifts again: louder, faster, more energetic. Set the stakes: 'One sensor is lying. Find which one, and explain how.' Tell them: '3-4 student teams. 25 minutes. First team to identify all three attacks wins.'</a:t>
+              <a:t>Okay, we're back. Activity 2 is different. This is a competition. You'll work in teams. The first team to identify all three attacks correctly gets bragging rights for the day. Here's the setup. One of engine 17's sensors is reporting bad data. You don't know which sensor. You don't know what kind of attack. Your job is to find both.</a:t>
             </a:r>
           </a:p>
         </p:txBody>
@@ -2587,7 +2587,7 @@
           <a:lstStyle/>
           <a:p>
             <a:r>
-              <a:t>Read the maintenance ops quote aloud, slowly. Sell the urgency. Then introduce the two models: their own soft tree from Activity 1, plus a RandomForest baseline as the black-box comparison. Tell them the same investigation technique works whether the cause is hardware failure or adversarial attack.</a:t>
+              <a:t>Imagine you're the data science team at an airline. Maintenance ops just sent you a message. Something is wrong with engine 17. The pattern looks like a sensor drift, a frozen sensor, or noise spikes, but we can't tell which channel is at fault. Localize the faulty sensor before the next flight. You have two tools. Your Soft Decision Tree from Activity 1, which is explainable. And we'll add a RandomForest baseline, which is more accurate but opaque. Use both. See which one is actually useful.</a:t>
             </a:r>
           </a:p>
         </p:txBody>
@@ -2657,7 +2657,7 @@
           <a:lstStyle/>
           <a:p>
             <a:r>
-              <a:t>Give them 30 seconds to form groups. Most rooms organize themselves; do not micromanage. Emphasize the time budget (17 minutes of analysis) and the prize (bragging rights for the winning team). Announce that you will walk around and give hints, but will not give the answer.</a:t>
+              <a:t>Okay. Form groups of three to four people. Pick the people next to you. Thirty seconds. Use one notebook per team. One person types, the others think and argue. Once we start the clock you have seventeen minutes for analysis. First team to identify all three correctly — sensor and attack type for each file — wins.</a:t>
             </a:r>
           </a:p>
         </p:txBody>
@@ -2727,7 +2727,7 @@
           <a:lstStyle/>
           <a:p>
             <a:r>
-              <a:t>Walk through the three attack files and the corresponding attack types. Drift: a constant offset added to one sensor for all cycles. Stuck-at: a sensor frozen at a single value. Noise: Gaussian noise added to one sensor. Each file is a corrupted copy of engine 17. Same engine, three different manipulations.</a:t>
+              <a:t>Three files. Attack A is a drift: a sensor with a constant offset added. Attack B is stuck-at: a sensor frozen at a single value. Attack C is Gaussian noise: a sensor with random noise injected. All three files are copies of clean engine 17 data, but in each one, exactly one sensor channel has been manipulated. Find which one.</a:t>
             </a:r>
           </a:p>
         </p:txBody>
@@ -2797,7 +2797,7 @@
           <a:lstStyle/>
           <a:p>
             <a:r>
-              <a:t>Step 1, add a RandomForest baseline. The two models reach nearly identical accuracy. The difference will appear under attack, not on clean data.</a:t>
+              <a:t>First, we add a RandomForest baseline. Same data, same labels. When you run this, you should see two accuracies: SoftTree around 0.841, RandomForest around 0.843. Essentially identical on clean data. The whole point of this activity is showing what happens when we move OFF clean data.</a:t>
             </a:r>
           </a:p>
         </p:txBody>
@@ -2867,7 +2867,7 @@
           <a:lstStyle/>
           <a:p>
             <a:r>
-              <a:t>Slow this slide down. Read the title aloud: 'A turbofan engine. When will it fail?' Then stop. Do not fill the silence. Two to three seconds. Then read the smaller line: 'If you knew with certainty, what would you do differently?' Let the audience think about it. Do not call on anyone. Move on after a beat.</a:t>
+              <a:t>So. A turbofan engine. The question is, when will it fail? Think about it for a moment. If you knew with certainty, exactly when this engine would fail, what would you do differently than what airlines do today? I'm not going to call on anybody. Just hold that question in your head as we go.</a:t>
             </a:r>
           </a:p>
         </p:txBody>
@@ -2937,7 +2937,7 @@
           <a:lstStyle/>
           <a:p>
             <a:r>
-              <a:t>Step 2 establishes the clean baseline. The two models agree on 95 percent of cycles. We will use this baseline to measure how much each attack changes predictions.</a:t>
+              <a:t>Now we load the clean engine 17 file. This is the reference — the un-attacked version. We run both models on it and store the predictions. After this you should see two hundred and seventy-six cycles, and the two models agree on ninety-five percent of them. That's our baseline. When reality is normal, the two models say the same thing.</a:t>
             </a:r>
           </a:p>
         </p:txBody>
@@ -3007,7 +3007,7 @@
           <a:lstStyle/>
           <a:p>
             <a:r>
-              <a:t>Step 3 is the first big insight. The RandomForest on Attack C changed its prediction at only one cycle out of 276. It is essentially blind to the attack. The Soft Tree caught 8 cycles. This is the explainable model not just being interpretable but also being more sensitive to subtle manipulations.</a:t>
+              <a:t>Now we run both models on each of the three attack files and compare against the clean baseline. Read your output carefully. Attack A: tree changed eighteen cycles, RandomForest changed fourteen. Attack B: tree changed thirty-three, RandomForest changed eight. Attack C — and this is the one — tree changed eight, RandomForest changed only one. The RandomForest barely noticed Attack C. It says 'everything looks fine' when in reality a sensor is broken. The Soft Tree caught eight cycles. The explainable model is also the more sensitive one to subtle manipulations. That's not a coincidence.</a:t>
             </a:r>
           </a:p>
         </p:txBody>
@@ -3077,7 +3077,7 @@
           <a:lstStyle/>
           <a:p>
             <a:r>
-              <a:t>Step 4 visualizes attack A. Drift looks like two parallel lines: the attack copy of one sensor is shifted up by a constant amount. Answer is sensor 11.</a:t>
+              <a:t>Now we visualize Attack A. We plot each sensor twice. Clean in blue, attack in orange. Fourteen of the fifteen panels will show only one line, because the blue and orange overlap exactly. But ONE panel will show two separate lines. That's your manipulated sensor. Look carefully. Which sensor is it? If you see two parallel lines — same shape, but shifted — that's drift. A constant offset. The answer is sensor 11.</a:t>
             </a:r>
           </a:p>
         </p:txBody>
@@ -3147,7 +3147,7 @@
           <a:lstStyle/>
           <a:p>
             <a:r>
-              <a:t>Step 5 visualizes attack B. Stuck-at: one sensor reports the same value for every cycle while the real value would be evolving. Answer is sensor 14, which is one of the model's pillars (we saw it in Activity 1, Step 10). Attackers go for what the model relies on.</a:t>
+              <a:t>Same plot, same logic, for Attack B. Look for the sensor where blue and orange diverge. This time the orange line will be completely flat. Frozen at one value, while the blue line keeps evolving. That's stuck-at. Which sensor? Sensor 14. Now think about this. Sensor 14 was a pillar of our model in Activity 1, Step 10. Whoever attacked engine 17 went after exactly what the model relies on the most. That's not a coincidence. That's how adversarial attacks work.</a:t>
             </a:r>
           </a:p>
         </p:txBody>
@@ -3217,7 +3217,7 @@
           <a:lstStyle/>
           <a:p>
             <a:r>
-              <a:t>Step 6 visualizes attack C. Noise injection is the subtlest of the three: the trend is preserved, only the variance increases. Hardest to detect visually. Answer is sensor 9.</a:t>
+              <a:t>Attack C is the subtlest one. Look at all fifteen panels. In one of them, the orange line follows the same trend as blue, but it's noticeably more jagged. More wobbly. Same average, much higher variance. That's Gaussian noise. Which sensor? Sensor 9. This one is the hardest to catch visually because the overall trend is preserved. Only the noise level changes. That's why the RandomForest missed it. The trend was right, so it kept saying 'fine.'</a:t>
             </a:r>
           </a:p>
         </p:txBody>
@@ -3287,7 +3287,7 @@
           <a:lstStyle/>
           <a:p>
             <a:r>
-              <a:t>Step 7 quantifies what they already saw. Each attack file differs from clean engine 17 in exactly one sensor: 11, 14, or 9. The other sensors have zero divergence because they were not touched. Numbers are unambiguous.</a:t>
+              <a:t>Last step. Let's quantify what we just saw with our eyes. For each attack file, we compute the mean absolute difference between clean and attack for every sensor. Then we print the top three sensors that differ. After this runs, you should see: Attack A, sensor 11 first, the rest zero. Attack B, sensor 14 first with a huge number, nineteen point eight nine, the rest zero. Attack C, sensor 9 first, six point four two, the rest zero. Notice that for each attack, only ONE sensor differs at all. The other fourteen are perfectly identical. Attackers don't manipulate everything. They go after one sensor and try to stay hidden. Our model caught them anyway.</a:t>
             </a:r>
           </a:p>
         </p:txBody>
@@ -3357,7 +3357,7 @@
           <a:lstStyle/>
           <a:p>
             <a:r>
-              <a:t>Start a 17-minute timer. Visible on stage if possible. Walk around the room. Provoke wrong answers: when a team says 'sensor 11', ask 'are you sure? attack B has sensor 14 with score 19.89, isn't that bigger?' Force them to explain their reasoning back to you.</a:t>
+              <a:t>Okay, seventeen minutes on the clock starting now. Open activity 2 student notebook on your laptop. Discuss with your team. I'm walking around. If you have questions, raise a hand. I'll give hints, but I won't give you the answer. Go.</a:t>
             </a:r>
           </a:p>
         </p:txBody>
@@ -3427,7 +3427,7 @@
           <a:lstStyle/>
           <a:p>
             <a:r>
-              <a:t>Reveal the answers. Read them out: sensor 11 drift, sensor 14 stuck-at, sensor 9 noise. Ask who got all three. Applaud the winning team. Energy spike, then we transition into the analysis slide.</a:t>
+              <a:t>Okay, time's up. Here are the answers. Attack A is sensor 11, drift. Attack B is sensor 14, stuck-at. Attack C is sensor 9, Gaussian noise. Show of hands — which team got all three? Round of applause for them.</a:t>
             </a:r>
           </a:p>
         </p:txBody>
@@ -3497,7 +3497,7 @@
           <a:lstStyle/>
           <a:p>
             <a:r>
-              <a:t>The teaching point. Explainability is not just about audits. It is also a debugging tool. If a sensor goes bad in production, the model itself can tell you which sensor. The same technique that satisfies the FAA also helps your maintenance engineers find the broken hardware.</a:t>
+              <a:t>Here's what we just demonstrated. The RandomForest changed its prediction under attack, but it couldn't tell you which sensor caused the change. The Soft Decision Tree's split weights shifted in a sensor-specific way. That shift IS the explanation. It's a fingerprint of which sensor the model is leaning on. And here's the lesson. Explainability isn't just for regulatory compliance. It's also a debugging tool. The same property that lets you defend a model to the FAA also helps your maintenance engineers find the broken hardware. That's the takeaway.</a:t>
             </a:r>
           </a:p>
         </p:txBody>
@@ -3567,7 +3567,7 @@
           <a:lstStyle/>
           <a:p>
             <a:r>
-              <a:t>Activity 3 is a different kind of value. Tell them: 'For the last 15 minutes, you are going to make a real open-source contribution. Not a workshop exercise. A real pull request to a real library that is on PyPI. Your name on it, on GitHub, forever.' Energy should be high here. This is also the segment that builds your EB-1A evidence.</a:t>
+              <a:t>Okay, last fifteen minutes. This part is different from everything else. You're going to make a real open-source contribution to a real Python library that's on PyPI. Not a workshop exercise. A real pull request that I will review and merge live, in front of you, right now. Your name on it. Forever.</a:t>
             </a:r>
           </a:p>
         </p:txBody>
@@ -3637,7 +3637,7 @@
           <a:lstStyle/>
           <a:p>
             <a:r>
-              <a:t>Three failure modes. Read them aloud, one beat between each. Notice the third one is the one that surprises engineers: 'accurate but unexplainable still gets rejected.' Land on the bottom line: 'Accuracy alone is not enough. You also need to defend the prediction.' This is the thesis of the entire workshop. Say it slowly.</a:t>
+              <a:t>Here's why this is hard. There are three ways to be wrong, and all three are expensive. One: you predict too late. The engine fails in flight. You lose lives. Two: you predict too early. You pull a perfectly good engine out of service. Each engine is about a hundred million dollars. Three, and this is the one engineers forget: you predict accurately, but you can't explain how. In that case, the FAA refuses to certify your system. You can have the best model in the world; if you can't defend it, it doesn't fly. That's the whole point. Accuracy by itself is not enough. You also need to defend the prediction.</a:t>
             </a:r>
           </a:p>
         </p:txBody>
@@ -3707,7 +3707,7 @@
           <a:lstStyle/>
           <a:p>
             <a:r>
-              <a:t>Walk through the mechanics. Five steps. Emphasize step 5: 'I will review live. If your PR is correct, I merge it on the spot, and your name goes into the contributors list of a real ML library.' Roughly 20 good first issues are waiting; they range from doc fixes to small tests to runnable examples.</a:t>
+              <a:t>Here's how it works. Open github.com/cgrtml/neural-trees. Go to the Issues tab. Filter by good first issue. Pick one — they're all ten to twenty minute scope. Comment 'I'm taking this' so two people don't pick the same one. Fork the repo, make the change in your fork, open a pull request. I'll review it from my laptop right here on stage. If it's correct, I merge it on the spot. There are about twenty issues waiting. Pick what fits your level.</a:t>
             </a:r>
           </a:p>
         </p:txBody>
@@ -3777,7 +3777,7 @@
           <a:lstStyle/>
           <a:p>
             <a:r>
-              <a:t>Sell the value: a real OSS contribution is a credential that opens doors. Recruiters see it on GitHub. Internship applications. Grad school. Every merged PR also gets credited in the neural-trees README under WSU Workshop Contributors. Then say: 'Open the repo. Pick an issue. Go.' Then walk to your laptop and start reviewing.</a:t>
+              <a:t>Why is this worth fifteen minutes of your day? Three reasons. One. Your contribution shows up on your GitHub profile. That's visible to recruiters, internship coordinators, grad school admissions. It's a credential that's much harder to fake than a tutorial certificate. Two. You become part of a Python package that other people install with pip. Your code runs on their machines. Three. Every merged PR will be credited in the neural-trees README under a section called WSU Workshop Contributors. That section will exist after today, with your names on it. Open the repo. Pick an issue. Go.</a:t>
             </a:r>
           </a:p>
         </p:txBody>
@@ -3847,7 +3847,7 @@
           <a:lstStyle/>
           <a:p>
             <a:r>
-              <a:t>Connect the workshop to the regulatory landscape. EU AI Act took effect in 2025. Three articles matter for what we did today: Article 13 is transparency, Article 14 is human oversight, Article 15 is robustness. Tell them this is happening in the US too: SR 11-7 for banking, FDA for medical devices, FAA for aviation. Same direction, different agencies.</a:t>
+              <a:t>Quick context for why all of this matters in the real world. The EU AI Act took effect in 2025. If your AI system serves any European customer, three articles apply. Article 13: transparency. Article 14: human oversight. Article 15: robustness against adversarial inputs and faults. The exact things we did today. And the US is moving in the same direction. SR 11-7 for banking. FDA for medical devices. FAA for aviation. The era of just-ship-the-LSTM is ending. The era of show-your-work is starting.</a:t>
             </a:r>
           </a:p>
         </p:txBody>
@@ -3917,7 +3917,7 @@
           <a:lstStyle/>
           <a:p>
             <a:r>
-              <a:t>Three takeaways. Read each headline aloud. The subline explains it but does not need to be read verbatim. Lean on point 3: 'You ran this. Not me. Not a video. You.' Then transition into the career bridge.</a:t>
+              <a:t>Three things to take with you. One: in safety-critical AI, explainability is not optional. It's a regulatory requirement. Two: Soft Decision Trees give you both worlds. Neural-network-level accuracy with tree-level interpretability. Three: you actually did this. Not me. Not a video. You. You trained a model, you localized a sensor fault, and many of you just shipped your first open-source contribution.</a:t>
             </a:r>
           </a:p>
         </p:txBody>
@@ -3987,7 +3987,7 @@
           <a:lstStyle/>
           <a:p>
             <a:r>
-              <a:t>Open the door. Tell them where this work goes next: banking model risk, insurance, healthcare, aerospace. Mention Hezarfen and the SR 11-7 angle. Then make the explicit invitation: 'Thesis topic, open-source contribution, conversation. Reach out.' This is your funnel-top moment for the strongest students in the room.</a:t>
+              <a:t>Where does this work go next? Banks, insurers, healthcare, aerospace. Every regulated industry needs explainable AI right now. My company Hezarfen builds compliance-ready AI for US mid-market banks under SR 11-7 and the EU AI Act. If anything you saw today interests you — a thesis topic, an open-source contribution, internship questions, or just a conversation about where to go after graduation — reach out. My email and LinkedIn are on the next slide.</a:t>
             </a:r>
           </a:p>
         </p:txBody>
@@ -4057,7 +4057,7 @@
           <a:lstStyle/>
           <a:p>
             <a:r>
-              <a:t>Leave this slide up while you take questions. Students will photograph it. Read the three links out loud once.</a:t>
+              <a:t>Here are the three things worth bookmarking. My GitHub, where neural-trees lives. My LinkedIn — happy to connect with any of you. And the workshop repo on GitHub. Everything we did today is there: the data, the notebooks, the slides. Take a photo of this slide if you want.</a:t>
             </a:r>
           </a:p>
         </p:txBody>
@@ -4127,7 +4127,7 @@
           <a:lstStyle/>
           <a:p>
             <a:r>
-              <a:t>Close with the thank-you. Acknowledge Sergey and Jeremy by name. Offer five minutes for questions after the session officially ends. Stay near the stage; students will come up.</a:t>
+              <a:t>Thank you. Special thanks to Dr. Sergey Lapin and to Jeremy for the invitation. Without them this wouldn't have happened. I'll stay for five minutes after the official close. If you have questions, come up to the stage. If you want to follow up later, you have my email.</a:t>
             </a:r>
           </a:p>
         </p:txBody>
@@ -4197,7 +4197,7 @@
           <a:lstStyle/>
           <a:p>
             <a:r>
-              <a:t>Briefly describe CMAPSS: NASA's open dataset, 100 simulated engines, 21 sensors. Mention that this is the canonical benchmark for predictive maintenance research. Do not dwell on dataset history. Move on in under a minute. Students will load and explore this data themselves in Activity 1.</a:t>
+              <a:t>The dataset we'll use is called NASA CMAPSS. It's open, it's free, and it's been the standard benchmark in predictive maintenance for about fifteen years. A hundred turbofan engines, each one simulated all the way to failure. Twenty-one sensors per timestep: temperatures, pressures, fan speeds, fuel flow. Each engine logs hundreds of flight cycles before it dies. You'll be working with this data on your own laptop in twenty minutes.</a:t>
             </a:r>
           </a:p>
         </p:txBody>
@@ -4267,7 +4267,7 @@
           <a:lstStyle/>
           <a:p>
             <a:r>
-              <a:t>RUL is the supervised label. For each row in the training set, RUL equals max_cycle for that engine minus current cycle. Healthy engines have large RUL, dying engines have small RUL. We will cap RUL at 125 in the notebook because predicting more than 125 cycles ahead is not informative. This is standard practice in CMAPSS work.</a:t>
+              <a:t>The thing we're going to predict is called RUL, Remaining Useful Life. It's the number of flight cycles left before the engine fails. So if an engine fails at cycle 192, at cycle 100 its RUL is 92. At cycle 190 it's 2. At failure it's zero. We cap RUL at 125 because predicting further than that ahead isn't useful. Past 125 cycles, you're just guessing about the future.</a:t>
             </a:r>
           </a:p>
         </p:txBody>
@@ -4337,7 +4337,7 @@
           <a:lstStyle/>
           <a:p>
             <a:r>
-              <a:t>Don't read every row. Point at the three highlighted sensors: s7 (HPC outlet pressure), s11 (static pressure), s14 (corrected core speed). Tell the audience: 'Remember these three. They will show up again in Activity 1 as the most important features, and in Activity 2 as the sensors that get attacked.' Move on in under a minute.</a:t>
+              <a:t>For every cycle, we get 21 sensor readings. Don't try to memorize them. But three of them I want you to notice now, because they'll come back later. Sensor 7, high-pressure compressor outlet pressure. Sensor 11, static pressure. Sensor 14, corrected core speed. These three are the model's favorites. Remember those names. They show up again in Activity 2 when one of them gets attacked.</a:t>
             </a:r>
           </a:p>
         </p:txBody>
@@ -4407,7 +4407,7 @@
           <a:lstStyle/>
           <a:p>
             <a:r>
-              <a:t>Show the result and read it: 'LSTM, two layers, RMSE 15.49 cycles, R-squared 0.855.' Then deliver the loaded question: 'So we ship it to the FAA, right?' Lean into the implicit setup. The next slide is the answer.</a:t>
+              <a:t>Here's the modern approach. We throw an LSTM at it. A two-layer recurrent neural network. After training, the LSTM gets an RMSE of 15.49 cycles, R-squared 0.855. That's pretty good. About fifteen cycles off, on average. So... we ship it to the FAA, right?</a:t>
             </a:r>
           </a:p>
         </p:txBody>

</xml_diff>

<commit_message>
GitHub Sprint: explicit fork + dot-key web-editor workflow; landing page prerequisites
Slide 50 (Sprint Mechanics) now lists seven concrete steps with the dot-key
trick highlighted: students press '.' on their keyboard inside their fork to
launch the full GitHub web editor, no local git required. Same change is
mirrored in the PowerPoint deck, speaker notes inside the pptx, and the
Word-formatted spoken script.

The landing page (landing/index.html) gains a Before-you-arrive section
listing the two prerequisites: a Google account for Colab, and a GitHub
account for the contribution sprint. Linked to github.com/signup so anyone
without an account can create one before May 15.
</commit_message>
<xml_diff>
--- a/WSU-Workshop-May15.pptx
+++ b/WSU-Workshop-May15.pptx
@@ -3707,7 +3707,7 @@
           <a:lstStyle/>
           <a:p>
             <a:r>
-              <a:t>Here's how it works. Open github.com/cgrtml/neural-trees. Go to the Issues tab. Filter by good first issue. Pick one — they're all ten to twenty minute scope. Comment 'I'm taking this' so two people don't pick the same one. Fork the repo, make the change in your fork, open a pull request. I'll review it from my laptop right here on stage. If it's correct, I merge it on the spot. There are about twenty issues waiting. Pick what fits your level.</a:t>
+              <a:t>Here's how it works. Seven steps. Open github.com/cgrtml/neural-trees. Go to the Issues tab. Filter by good first issue. Pick one — they're all ten to twenty minute scope. Comment 'I'm taking this' so two people don't pick the same one. Then click Fork in the top right. That gives you your own copy of the repo. Open the file you want to edit IN YOUR FORK, not in mine. And here's the trick that saves you ten minutes: press the dot key on your keyboard. GitHub's full web editor opens. You can edit there like in VS Code. Commit on a new branch, then click 'Compare and pull request,' add a short description, and open the PR. I'll review it from my laptop right here on stage. If it's correct, I merge it on the spot. No local git. No clone. No tokens. Everything in the browser. There are about twenty issues waiting. Pick what fits your level.</a:t>
             </a:r>
           </a:p>
         </p:txBody>
@@ -22722,8 +22722,8 @@
         </p:nvSpPr>
         <p:spPr>
           <a:xfrm>
-            <a:off x="548640" y="640080"/>
-            <a:ext cx="10972800" cy="914400"/>
+            <a:off x="548640" y="457200"/>
+            <a:ext cx="10972800" cy="731520"/>
           </a:xfrm>
           <a:prstGeom prst="rect">
             <a:avLst/>
@@ -22738,7 +22738,7 @@
           <a:p>
             <a:pPr algn="l"/>
             <a:r>
-              <a:rPr sz="4000" b="1" i="0">
+              <a:rPr sz="3600" b="1" i="0">
                 <a:solidFill>
                   <a:srgbClr val="4FC3F7"/>
                 </a:solidFill>
@@ -22757,8 +22757,8 @@
         </p:nvSpPr>
         <p:spPr>
           <a:xfrm>
-            <a:off x="731520" y="1828800"/>
-            <a:ext cx="10972800" cy="4572000"/>
+            <a:off x="640080" y="1371600"/>
+            <a:ext cx="11247120" cy="4572000"/>
           </a:xfrm>
           <a:prstGeom prst="rect">
             <a:avLst/>
@@ -22776,11 +22776,11 @@
                 <a:spcPct val="120000"/>
               </a:lnSpc>
               <a:spcAft>
-                <a:spcPts val="1400"/>
+                <a:spcPts val="1000"/>
               </a:spcAft>
             </a:pPr>
             <a:r>
-              <a:rPr sz="1800" b="0" i="0">
+              <a:rPr sz="1500" b="0" i="0">
                 <a:solidFill>
                   <a:srgbClr val="EEEEEE"/>
                 </a:solidFill>
@@ -22795,17 +22795,17 @@
                 <a:spcPct val="120000"/>
               </a:lnSpc>
               <a:spcAft>
-                <a:spcPts val="1400"/>
+                <a:spcPts val="1000"/>
               </a:spcAft>
             </a:pPr>
             <a:r>
-              <a:rPr sz="1800" b="0" i="0">
+              <a:rPr sz="1500" b="0" i="0">
                 <a:solidFill>
                   <a:srgbClr val="EEEEEE"/>
                 </a:solidFill>
                 <a:latin typeface="Helvetica Neue"/>
               </a:rPr>
-              <a:t>2. Filter by label: good first issue. Pick one (10 to 20 min scope)</a:t>
+              <a:t>2. Filter by label "good first issue". Pick one (10 to 20 min scope)</a:t>
             </a:r>
           </a:p>
           <a:p>
@@ -22814,11 +22814,11 @@
                 <a:spcPct val="120000"/>
               </a:lnSpc>
               <a:spcAft>
-                <a:spcPts val="1400"/>
+                <a:spcPts val="1000"/>
               </a:spcAft>
             </a:pPr>
             <a:r>
-              <a:rPr sz="1800" b="0" i="0">
+              <a:rPr sz="1500" b="0" i="0">
                 <a:solidFill>
                   <a:srgbClr val="EEEEEE"/>
                 </a:solidFill>
@@ -22833,17 +22833,17 @@
                 <a:spcPct val="120000"/>
               </a:lnSpc>
               <a:spcAft>
-                <a:spcPts val="1400"/>
+                <a:spcPts val="1000"/>
               </a:spcAft>
             </a:pPr>
             <a:r>
-              <a:rPr sz="1800" b="0" i="0">
+              <a:rPr sz="1500" b="1" i="0">
                 <a:solidFill>
                   <a:srgbClr val="EEEEEE"/>
                 </a:solidFill>
                 <a:latin typeface="Helvetica Neue"/>
               </a:rPr>
-              <a:t>4. Fork the repo, edit, open a PR</a:t>
+              <a:t>4. Fork the repo (top-right button). Open the file you want to edit IN YOUR FORK.</a:t>
             </a:r>
           </a:p>
           <a:p>
@@ -22852,17 +22852,55 @@
                 <a:spcPct val="120000"/>
               </a:lnSpc>
               <a:spcAft>
-                <a:spcPts val="1400"/>
+                <a:spcPts val="1000"/>
               </a:spcAft>
             </a:pPr>
             <a:r>
-              <a:rPr sz="1800" b="0" i="0">
+              <a:rPr sz="1500" b="0" i="0">
+                <a:solidFill>
+                  <a:srgbClr val="4FC3F7"/>
+                </a:solidFill>
+                <a:latin typeface="Helvetica Neue"/>
+              </a:rPr>
+              <a:t>5. Press the "." key on your keyboard. GitHub web editor opens. Edit. Commit on a new branch.</a:t>
+            </a:r>
+          </a:p>
+          <a:p>
+            <a:pPr algn="l">
+              <a:lnSpc>
+                <a:spcPct val="120000"/>
+              </a:lnSpc>
+              <a:spcAft>
+                <a:spcPts val="1000"/>
+              </a:spcAft>
+            </a:pPr>
+            <a:r>
+              <a:rPr sz="1500" b="0" i="0">
+                <a:solidFill>
+                  <a:srgbClr val="EEEEEE"/>
+                </a:solidFill>
+                <a:latin typeface="Helvetica Neue"/>
+              </a:rPr>
+              <a:t>6. Click "Compare &amp; pull request". Short description. Open the PR.</a:t>
+            </a:r>
+          </a:p>
+          <a:p>
+            <a:pPr algn="l">
+              <a:lnSpc>
+                <a:spcPct val="120000"/>
+              </a:lnSpc>
+              <a:spcAft>
+                <a:spcPts val="1000"/>
+              </a:spcAft>
+            </a:pPr>
+            <a:r>
+              <a:rPr sz="1500" b="1" i="0">
                 <a:solidFill>
                   <a:srgbClr val="81C784"/>
                 </a:solidFill>
                 <a:latin typeface="Helvetica Neue"/>
               </a:rPr>
-              <a:t>5. I will review live. Simple PRs get merged on the spot.</a:t>
+              <a:t>7. I will review live. Simple PRs get merged on the spot.</a:t>
             </a:r>
           </a:p>
         </p:txBody>
@@ -22875,7 +22913,7 @@
         </p:nvSpPr>
         <p:spPr>
           <a:xfrm>
-            <a:off x="548640" y="6126480"/>
+            <a:off x="548640" y="5852160"/>
             <a:ext cx="10972800" cy="365760"/>
           </a:xfrm>
           <a:prstGeom prst="rect">
@@ -22891,7 +22929,42 @@
           <a:p>
             <a:pPr algn="ctr"/>
             <a:r>
-              <a:rPr sz="1400" b="0" i="1">
+              <a:rPr sz="1300" b="0" i="1">
+                <a:solidFill>
+                  <a:srgbClr val="BBBBBB"/>
+                </a:solidFill>
+                <a:latin typeface="Helvetica Neue"/>
+              </a:rPr>
+              <a:t>No local git, no clone, no token. Everything in the browser.</a:t>
+            </a:r>
+          </a:p>
+        </p:txBody>
+      </p:sp>
+      <p:sp>
+        <p:nvSpPr>
+          <p:cNvPr id="5" name="TextBox 4"/>
+          <p:cNvSpPr txBox="1"/>
+          <p:nvPr/>
+        </p:nvSpPr>
+        <p:spPr>
+          <a:xfrm>
+            <a:off x="548640" y="6309360"/>
+            <a:ext cx="10972800" cy="365760"/>
+          </a:xfrm>
+          <a:prstGeom prst="rect">
+            <a:avLst/>
+          </a:prstGeom>
+          <a:noFill/>
+        </p:spPr>
+        <p:txBody>
+          <a:bodyPr wrap="square" lIns="0" rIns="0" tIns="0" bIns="0" anchor="t">
+            <a:spAutoFit/>
+          </a:bodyPr>
+          <a:lstStyle/>
+          <a:p>
+            <a:pPr algn="ctr"/>
+            <a:r>
+              <a:rPr sz="1300" b="0" i="1">
                 <a:solidFill>
                   <a:srgbClr val="4FC3F7"/>
                 </a:solidFill>

</xml_diff>